<commit_message>
Embed screenshots directly in PowerPoint slide layouts and update PDF build
</commit_message>
<xml_diff>
--- a/aetherfin_presentation.pptx
+++ b/aetherfin_presentation.pptx
@@ -4002,8 +4002,8 @@
         </p:nvSpPr>
         <p:spPr>
           <a:xfrm>
-            <a:off x="457200" y="1371600"/>
-            <a:ext cx="8229600" cy="4572000"/>
+            <a:off x="457200" y="1280160"/>
+            <a:ext cx="4114800" cy="3474720"/>
           </a:xfrm>
           <a:prstGeom prst="rect">
             <a:avLst/>
@@ -4018,105 +4018,129 @@
           <a:p>
             <a:pPr>
               <a:spcAft>
-                <a:spcPts val="1400"/>
-              </a:spcAft>
-            </a:pPr>
-            <a:r>
-              <a:rPr sz="1800" b="1">
-                <a:solidFill>
-                  <a:srgbClr val="FAFAFA"/>
-                </a:solidFill>
-                <a:latin typeface="Arial"/>
-              </a:rPr>
-              <a:t>Dashboard Interface (sizing.png):</a:t>
-            </a:r>
-            <a:r>
-              <a:rPr sz="1800">
-                <a:solidFill>
-                  <a:srgbClr val="A1A1AA"/>
-                </a:solidFill>
-                <a:latin typeface="Arial"/>
-              </a:rPr>
-              <a:t> KPI overview widgets, active node grid, and 48-hour utilization timelines.</a:t>
-            </a:r>
-          </a:p>
-          <a:p>
-            <a:pPr>
-              <a:spcAft>
-                <a:spcPts val="1400"/>
-              </a:spcAft>
-            </a:pPr>
-            <a:r>
-              <a:rPr sz="1800" b="1">
-                <a:solidFill>
-                  <a:srgbClr val="FAFAFA"/>
-                </a:solidFill>
-                <a:latin typeface="Arial"/>
-              </a:rPr>
-              <a:t>Outlier Analytics (anomalies.png):</a:t>
-            </a:r>
-            <a:r>
-              <a:rPr sz="1800">
-                <a:solidFill>
-                  <a:srgbClr val="A1A1AA"/>
-                </a:solidFill>
-                <a:latin typeface="Arial"/>
-              </a:rPr>
-              <a:t> Z-score outlier graphs detailing historical server spikes.</a:t>
-            </a:r>
-          </a:p>
-          <a:p>
-            <a:pPr>
-              <a:spcAft>
-                <a:spcPts val="1400"/>
-              </a:spcAft>
-            </a:pPr>
-            <a:r>
-              <a:rPr sz="1800" b="1">
-                <a:solidFill>
-                  <a:srgbClr val="FAFAFA"/>
-                </a:solidFill>
-                <a:latin typeface="Arial"/>
-              </a:rPr>
-              <a:t>KPI Drilldowns (drilldown.png):</a:t>
-            </a:r>
-            <a:r>
-              <a:rPr sz="1800">
-                <a:solidFill>
-                  <a:srgbClr val="A1A1AA"/>
-                </a:solidFill>
-                <a:latin typeface="Arial"/>
-              </a:rPr>
-              <a:t> Sliding sidebar panels displaying node-level cost allocations.</a:t>
-            </a:r>
-          </a:p>
-          <a:p>
-            <a:pPr>
-              <a:spcAft>
-                <a:spcPts val="1400"/>
-              </a:spcAft>
-            </a:pPr>
-            <a:r>
-              <a:rPr sz="1800" b="1">
-                <a:solidFill>
-                  <a:srgbClr val="FAFAFA"/>
-                </a:solidFill>
-                <a:latin typeface="Arial"/>
-              </a:rPr>
-              <a:t>Security &amp; Auditing Portal (admin_logs.png):</a:t>
-            </a:r>
-            <a:r>
-              <a:rPr sz="1800">
-                <a:solidFill>
-                  <a:srgbClr val="A1A1AA"/>
-                </a:solidFill>
-                <a:latin typeface="Arial"/>
-              </a:rPr>
-              <a:t> Immutable transaction log tables displaying JWT user activity.</a:t>
-            </a:r>
-          </a:p>
-        </p:txBody>
-      </p:sp>
+                <a:spcPts val="1000"/>
+              </a:spcAft>
+            </a:pPr>
+            <a:r>
+              <a:rPr sz="1300" b="1">
+                <a:solidFill>
+                  <a:srgbClr val="FAFAFA"/>
+                </a:solidFill>
+                <a:latin typeface="Arial"/>
+              </a:rPr>
+              <a:t>Dashboard (sizing.png):</a:t>
+            </a:r>
+            <a:r>
+              <a:rPr sz="1300">
+                <a:solidFill>
+                  <a:srgbClr val="A1A1AA"/>
+                </a:solidFill>
+                <a:latin typeface="Arial"/>
+              </a:rPr>
+              <a:t> Features the high-level KPI overview panels showing spend and carbon footprint details.</a:t>
+            </a:r>
+          </a:p>
+          <a:p>
+            <a:pPr>
+              <a:spcAft>
+                <a:spcPts val="1000"/>
+              </a:spcAft>
+            </a:pPr>
+            <a:r>
+              <a:rPr sz="1300" b="1">
+                <a:solidFill>
+                  <a:srgbClr val="FAFAFA"/>
+                </a:solidFill>
+                <a:latin typeface="Arial"/>
+              </a:rPr>
+              <a:t>Compute Activity:</a:t>
+            </a:r>
+            <a:r>
+              <a:rPr sz="1300">
+                <a:solidFill>
+                  <a:srgbClr val="A1A1AA"/>
+                </a:solidFill>
+                <a:latin typeface="Arial"/>
+              </a:rPr>
+              <a:t> Renders the active 48-hour timeline detailing node utilization and load fluctuations.</a:t>
+            </a:r>
+          </a:p>
+          <a:p>
+            <a:pPr>
+              <a:spcAft>
+                <a:spcPts val="1000"/>
+              </a:spcAft>
+            </a:pPr>
+            <a:r>
+              <a:rPr sz="1300" b="1">
+                <a:solidFill>
+                  <a:srgbClr val="FAFAFA"/>
+                </a:solidFill>
+                <a:latin typeface="Arial"/>
+              </a:rPr>
+              <a:t>Node Inventory:</a:t>
+            </a:r>
+            <a:r>
+              <a:rPr sz="1300">
+                <a:solidFill>
+                  <a:srgbClr val="A1A1AA"/>
+                </a:solidFill>
+                <a:latin typeface="Arial"/>
+              </a:rPr>
+              <a:t> Renders active database logs of multi-cloud allocations.</a:t>
+            </a:r>
+          </a:p>
+          <a:p>
+            <a:pPr>
+              <a:spcAft>
+                <a:spcPts val="1000"/>
+              </a:spcAft>
+            </a:pPr>
+            <a:r>
+              <a:rPr sz="1300" b="1">
+                <a:solidFill>
+                  <a:srgbClr val="FAFAFA"/>
+                </a:solidFill>
+                <a:latin typeface="Arial"/>
+              </a:rPr>
+              <a:t>One-Click Exports:</a:t>
+            </a:r>
+            <a:r>
+              <a:rPr sz="1300">
+                <a:solidFill>
+                  <a:srgbClr val="A1A1AA"/>
+                </a:solidFill>
+                <a:latin typeface="Arial"/>
+              </a:rPr>
+              <a:t> Stream summaries and audit trails directly to CSV or formatted text reports.</a:t>
+            </a:r>
+          </a:p>
+        </p:txBody>
+      </p:sp>
+      <p:pic>
+        <p:nvPicPr>
+          <p:cNvPr id="4" name="Picture 3" descr="sizing.png"/>
+          <p:cNvPicPr>
+            <a:picLocks noChangeAspect="1"/>
+          </p:cNvPicPr>
+          <p:nvPr/>
+        </p:nvPicPr>
+        <p:blipFill>
+          <a:blip r:embed="rId2"/>
+          <a:stretch>
+            <a:fillRect/>
+          </a:stretch>
+        </p:blipFill>
+        <p:spPr>
+          <a:xfrm>
+            <a:off x="4754880" y="1280160"/>
+            <a:ext cx="3931920" cy="2232184"/>
+          </a:xfrm>
+          <a:prstGeom prst="rect">
+            <a:avLst/>
+          </a:prstGeom>
+        </p:spPr>
+      </p:pic>
     </p:spTree>
   </p:cSld>
   <p:clrMapOvr>
@@ -4187,8 +4211,8 @@
         </p:nvSpPr>
         <p:spPr>
           <a:xfrm>
-            <a:off x="457200" y="1371600"/>
-            <a:ext cx="8229600" cy="4572000"/>
+            <a:off x="457200" y="1280160"/>
+            <a:ext cx="4114800" cy="3474720"/>
           </a:xfrm>
           <a:prstGeom prst="rect">
             <a:avLst/>
@@ -4203,11 +4227,61 @@
           <a:p>
             <a:pPr>
               <a:spcAft>
-                <a:spcPts val="1400"/>
-              </a:spcAft>
-            </a:pPr>
-            <a:r>
-              <a:rPr sz="1800" b="1">
+                <a:spcPts val="1000"/>
+              </a:spcAft>
+            </a:pPr>
+            <a:r>
+              <a:rPr sz="1300" b="1">
+                <a:solidFill>
+                  <a:srgbClr val="FAFAFA"/>
+                </a:solidFill>
+                <a:latin typeface="Arial"/>
+              </a:rPr>
+              <a:t>Interactive Sidebar (drilldown.png):</a:t>
+            </a:r>
+            <a:r>
+              <a:rPr sz="1300">
+                <a:solidFill>
+                  <a:srgbClr val="A1A1AA"/>
+                </a:solidFill>
+                <a:latin typeface="Arial"/>
+              </a:rPr>
+              <a:t> Opens node-level financial details dynamically on click.</a:t>
+            </a:r>
+          </a:p>
+          <a:p>
+            <a:pPr>
+              <a:spcAft>
+                <a:spcPts val="1000"/>
+              </a:spcAft>
+            </a:pPr>
+            <a:r>
+              <a:rPr sz="1300" b="1">
+                <a:solidFill>
+                  <a:srgbClr val="FAFAFA"/>
+                </a:solidFill>
+                <a:latin typeface="Arial"/>
+              </a:rPr>
+              <a:t>Visual Sizing Factors:</a:t>
+            </a:r>
+            <a:r>
+              <a:rPr sz="1300">
+                <a:solidFill>
+                  <a:srgbClr val="A1A1AA"/>
+                </a:solidFill>
+                <a:latin typeface="Arial"/>
+              </a:rPr>
+              <a:t> CFOs can drill down to see exact provider and regional billing components.</a:t>
+            </a:r>
+          </a:p>
+          <a:p>
+            <a:pPr>
+              <a:spcAft>
+                <a:spcPts val="1000"/>
+              </a:spcAft>
+            </a:pPr>
+            <a:r>
+              <a:rPr sz="1300" b="1">
                 <a:solidFill>
                   <a:srgbClr val="FAFAFA"/>
                 </a:solidFill>
@@ -4216,7 +4290,7 @@
               <a:t>Multi-Range Filters:</a:t>
             </a:r>
             <a:r>
-              <a:rPr sz="1800">
+              <a:rPr sz="1300">
                 <a:solidFill>
                   <a:srgbClr val="A1A1AA"/>
                 </a:solidFill>
@@ -4228,36 +4302,11 @@
           <a:p>
             <a:pPr>
               <a:spcAft>
-                <a:spcPts val="1400"/>
-              </a:spcAft>
-            </a:pPr>
-            <a:r>
-              <a:rPr sz="1800" b="1">
-                <a:solidFill>
-                  <a:srgbClr val="FAFAFA"/>
-                </a:solidFill>
-                <a:latin typeface="Arial"/>
-              </a:rPr>
-              <a:t>Diurnal Load Profiles:</a:t>
-            </a:r>
-            <a:r>
-              <a:rPr sz="1800">
-                <a:solidFill>
-                  <a:srgbClr val="A1A1AA"/>
-                </a:solidFill>
-                <a:latin typeface="Arial"/>
-              </a:rPr>
-              <a:t> Identifies node demand spikes (peak hours 9 AM - 6 PM) to plan scheduling.</a:t>
-            </a:r>
-          </a:p>
-          <a:p>
-            <a:pPr>
-              <a:spcAft>
-                <a:spcPts val="1400"/>
-              </a:spcAft>
-            </a:pPr>
-            <a:r>
-              <a:rPr sz="1800" b="1">
+                <a:spcPts val="1000"/>
+              </a:spcAft>
+            </a:pPr>
+            <a:r>
+              <a:rPr sz="1300" b="1">
                 <a:solidFill>
                   <a:srgbClr val="FAFAFA"/>
                 </a:solidFill>
@@ -4266,7 +4315,7 @@
               <a:t>Cohort Analysis:</a:t>
             </a:r>
             <a:r>
-              <a:rPr sz="1800">
+              <a:rPr sz="1300">
                 <a:solidFill>
                   <a:srgbClr val="A1A1AA"/>
                 </a:solidFill>
@@ -4275,33 +4324,32 @@
               <a:t> Compares model execution profiles to pinpoint underperforming instances.</a:t>
             </a:r>
           </a:p>
-          <a:p>
-            <a:pPr>
-              <a:spcAft>
-                <a:spcPts val="1400"/>
-              </a:spcAft>
-            </a:pPr>
-            <a:r>
-              <a:rPr sz="1800" b="1">
-                <a:solidFill>
-                  <a:srgbClr val="FAFAFA"/>
-                </a:solidFill>
-                <a:latin typeface="Arial"/>
-              </a:rPr>
-              <a:t>Green Savings Tracking:</a:t>
-            </a:r>
-            <a:r>
-              <a:rPr sz="1800">
-                <a:solidFill>
-                  <a:srgbClr val="A1A1AA"/>
-                </a:solidFill>
-                <a:latin typeface="Arial"/>
-              </a:rPr>
-              <a:t> Measures GICP improvements and emission reductions post-optimization.</a:t>
-            </a:r>
-          </a:p>
-        </p:txBody>
-      </p:sp>
+        </p:txBody>
+      </p:sp>
+      <p:pic>
+        <p:nvPicPr>
+          <p:cNvPr id="4" name="Picture 3" descr="drilldown.png"/>
+          <p:cNvPicPr>
+            <a:picLocks noChangeAspect="1"/>
+          </p:cNvPicPr>
+          <p:nvPr/>
+        </p:nvPicPr>
+        <p:blipFill>
+          <a:blip r:embed="rId2"/>
+          <a:stretch>
+            <a:fillRect/>
+          </a:stretch>
+        </p:blipFill>
+        <p:spPr>
+          <a:xfrm>
+            <a:off x="4754880" y="1280160"/>
+            <a:ext cx="3931920" cy="2232184"/>
+          </a:xfrm>
+          <a:prstGeom prst="rect">
+            <a:avLst/>
+          </a:prstGeom>
+        </p:spPr>
+      </p:pic>
     </p:spTree>
   </p:cSld>
   <p:clrMapOvr>
@@ -4372,8 +4420,8 @@
         </p:nvSpPr>
         <p:spPr>
           <a:xfrm>
-            <a:off x="457200" y="1371600"/>
-            <a:ext cx="8229600" cy="4572000"/>
+            <a:off x="457200" y="1280160"/>
+            <a:ext cx="4114800" cy="3474720"/>
           </a:xfrm>
           <a:prstGeom prst="rect">
             <a:avLst/>
@@ -4388,11 +4436,86 @@
           <a:p>
             <a:pPr>
               <a:spcAft>
-                <a:spcPts val="1400"/>
-              </a:spcAft>
-            </a:pPr>
-            <a:r>
-              <a:rPr sz="1800" b="1">
+                <a:spcPts val="1000"/>
+              </a:spcAft>
+            </a:pPr>
+            <a:r>
+              <a:rPr sz="1300" b="1">
+                <a:solidFill>
+                  <a:srgbClr val="FAFAFA"/>
+                </a:solidFill>
+                <a:latin typeface="Arial"/>
+              </a:rPr>
+              <a:t>Outliers Graph (anomalies.png):</a:t>
+            </a:r>
+            <a:r>
+              <a:rPr sz="1300">
+                <a:solidFill>
+                  <a:srgbClr val="A1A1AA"/>
+                </a:solidFill>
+                <a:latin typeface="Arial"/>
+              </a:rPr>
+              <a:t> Renders Z-score statistical outlier plots tracking latency spikes.</a:t>
+            </a:r>
+          </a:p>
+          <a:p>
+            <a:pPr>
+              <a:spcAft>
+                <a:spcPts val="1000"/>
+              </a:spcAft>
+            </a:pPr>
+            <a:r>
+              <a:rPr sz="1300" b="1">
+                <a:solidFill>
+                  <a:srgbClr val="FAFAFA"/>
+                </a:solidFill>
+                <a:latin typeface="Arial"/>
+              </a:rPr>
+              <a:t>Waste Alerts:</a:t>
+            </a:r>
+            <a:r>
+              <a:rPr sz="1300">
+                <a:solidFill>
+                  <a:srgbClr val="A1A1AA"/>
+                </a:solidFill>
+                <a:latin typeface="Arial"/>
+              </a:rPr>
+              <a:t> Automatically flags nodes operating under 10% average load for 12+ consecutive hours.</a:t>
+            </a:r>
+          </a:p>
+          <a:p>
+            <a:pPr>
+              <a:spcAft>
+                <a:spcPts val="1000"/>
+              </a:spcAft>
+            </a:pPr>
+            <a:r>
+              <a:rPr sz="1300" b="1">
+                <a:solidFill>
+                  <a:srgbClr val="FAFAFA"/>
+                </a:solidFill>
+                <a:latin typeface="Arial"/>
+              </a:rPr>
+              <a:t>Root Cause Diagnostics:</a:t>
+            </a:r>
+            <a:r>
+              <a:rPr sz="1300">
+                <a:solidFill>
+                  <a:srgbClr val="A1A1AA"/>
+                </a:solidFill>
+                <a:latin typeface="Arial"/>
+              </a:rPr>
+              <a:t> Automatically pairs anomalies with technical diagnoses and routing solutions.</a:t>
+            </a:r>
+          </a:p>
+          <a:p>
+            <a:pPr>
+              <a:spcAft>
+                <a:spcPts val="1000"/>
+              </a:spcAft>
+            </a:pPr>
+            <a:r>
+              <a:rPr sz="1300" b="1">
                 <a:solidFill>
                   <a:srgbClr val="FAFAFA"/>
                 </a:solidFill>
@@ -4401,7 +4524,7 @@
               <a:t>Dynamic Baselines:</a:t>
             </a:r>
             <a:r>
-              <a:rPr sz="1800">
+              <a:rPr sz="1300">
                 <a:solidFill>
                   <a:srgbClr val="A1A1AA"/>
                 </a:solidFill>
@@ -4410,83 +4533,32 @@
               <a:t> Avoids static thresholds by computing sliding-window mean and standard deviations.</a:t>
             </a:r>
           </a:p>
-          <a:p>
-            <a:pPr>
-              <a:spcAft>
-                <a:spcPts val="1400"/>
-              </a:spcAft>
-            </a:pPr>
-            <a:r>
-              <a:rPr sz="1800" b="1">
-                <a:solidFill>
-                  <a:srgbClr val="FAFAFA"/>
-                </a:solidFill>
-                <a:latin typeface="Arial"/>
-              </a:rPr>
-              <a:t>Latency Spikes:</a:t>
-            </a:r>
-            <a:r>
-              <a:rPr sz="1800">
-                <a:solidFill>
-                  <a:srgbClr val="A1A1AA"/>
-                </a:solidFill>
-                <a:latin typeface="Arial"/>
-              </a:rPr>
-              <a:t> Flags transactions exceeding a Z-score of 2.2 as high severity spikes.</a:t>
-            </a:r>
-          </a:p>
-          <a:p>
-            <a:pPr>
-              <a:spcAft>
-                <a:spcPts val="1400"/>
-              </a:spcAft>
-            </a:pPr>
-            <a:r>
-              <a:rPr sz="1800" b="1">
-                <a:solidFill>
-                  <a:srgbClr val="FAFAFA"/>
-                </a:solidFill>
-                <a:latin typeface="Arial"/>
-              </a:rPr>
-              <a:t>Idle Waste Warnings:</a:t>
-            </a:r>
-            <a:r>
-              <a:rPr sz="1800">
-                <a:solidFill>
-                  <a:srgbClr val="A1A1AA"/>
-                </a:solidFill>
-                <a:latin typeface="Arial"/>
-              </a:rPr>
-              <a:t> Triggers alerts for nodes running under 10% average load for 12+ consecutive hours.</a:t>
-            </a:r>
-          </a:p>
-          <a:p>
-            <a:pPr>
-              <a:spcAft>
-                <a:spcPts val="1400"/>
-              </a:spcAft>
-            </a:pPr>
-            <a:r>
-              <a:rPr sz="1800" b="1">
-                <a:solidFill>
-                  <a:srgbClr val="FAFAFA"/>
-                </a:solidFill>
-                <a:latin typeface="Arial"/>
-              </a:rPr>
-              <a:t>Root Cause Diagnostics:</a:t>
-            </a:r>
-            <a:r>
-              <a:rPr sz="1800">
-                <a:solidFill>
-                  <a:srgbClr val="A1A1AA"/>
-                </a:solidFill>
-                <a:latin typeface="Arial"/>
-              </a:rPr>
-              <a:t> Automatically pairs anomalies with technical diagnoses and routing solutions.</a:t>
-            </a:r>
-          </a:p>
-        </p:txBody>
-      </p:sp>
+        </p:txBody>
+      </p:sp>
+      <p:pic>
+        <p:nvPicPr>
+          <p:cNvPr id="4" name="Picture 3" descr="anomalies.png"/>
+          <p:cNvPicPr>
+            <a:picLocks noChangeAspect="1"/>
+          </p:cNvPicPr>
+          <p:nvPr/>
+        </p:nvPicPr>
+        <p:blipFill>
+          <a:blip r:embed="rId2"/>
+          <a:stretch>
+            <a:fillRect/>
+          </a:stretch>
+        </p:blipFill>
+        <p:spPr>
+          <a:xfrm>
+            <a:off x="4754880" y="1280160"/>
+            <a:ext cx="3931920" cy="2232184"/>
+          </a:xfrm>
+          <a:prstGeom prst="rect">
+            <a:avLst/>
+          </a:prstGeom>
+        </p:spPr>
+      </p:pic>
     </p:spTree>
   </p:cSld>
   <p:clrMapOvr>
@@ -4557,8 +4629,8 @@
         </p:nvSpPr>
         <p:spPr>
           <a:xfrm>
-            <a:off x="457200" y="1371600"/>
-            <a:ext cx="8229600" cy="4572000"/>
+            <a:off x="457200" y="1280160"/>
+            <a:ext cx="4114800" cy="3474720"/>
           </a:xfrm>
           <a:prstGeom prst="rect">
             <a:avLst/>
@@ -4573,105 +4645,129 @@
           <a:p>
             <a:pPr>
               <a:spcAft>
-                <a:spcPts val="1400"/>
-              </a:spcAft>
-            </a:pPr>
-            <a:r>
-              <a:rPr sz="1800" b="1">
-                <a:solidFill>
-                  <a:srgbClr val="FAFAFA"/>
-                </a:solidFill>
-                <a:latin typeface="Arial"/>
-              </a:rPr>
-              <a:t>Context Integration:</a:t>
-            </a:r>
-            <a:r>
-              <a:rPr sz="1800">
-                <a:solidFill>
-                  <a:srgbClr val="A1A1AA"/>
-                </a:solidFill>
-                <a:latin typeface="Arial"/>
-              </a:rPr>
-              <a:t> Feeds active cluster costs, idle penalties, and carbon metrics directly to the LLM context.</a:t>
-            </a:r>
-          </a:p>
-          <a:p>
-            <a:pPr>
-              <a:spcAft>
-                <a:spcPts val="1400"/>
-              </a:spcAft>
-            </a:pPr>
-            <a:r>
-              <a:rPr sz="1800" b="1">
-                <a:solidFill>
-                  <a:srgbClr val="FAFAFA"/>
-                </a:solidFill>
-                <a:latin typeface="Arial"/>
-              </a:rPr>
-              <a:t>Natural Language Interface:</a:t>
-            </a:r>
-            <a:r>
-              <a:rPr sz="1800">
-                <a:solidFill>
-                  <a:srgbClr val="A1A1AA"/>
-                </a:solidFill>
-                <a:latin typeface="Arial"/>
-              </a:rPr>
-              <a:t> Answering queries like 'How can I reduce costs by 20%?' or 'Which nodes are underperforming?'.</a:t>
-            </a:r>
-          </a:p>
-          <a:p>
-            <a:pPr>
-              <a:spcAft>
-                <a:spcPts val="1400"/>
-              </a:spcAft>
-            </a:pPr>
-            <a:r>
-              <a:rPr sz="1800" b="1">
-                <a:solidFill>
-                  <a:srgbClr val="FAFAFA"/>
-                </a:solidFill>
-                <a:latin typeface="Arial"/>
-              </a:rPr>
-              <a:t>Actionable Recommendations:</a:t>
-            </a:r>
-            <a:r>
-              <a:rPr sz="1800">
-                <a:solidFill>
-                  <a:srgbClr val="A1A1AA"/>
-                </a:solidFill>
-                <a:latin typeface="Arial"/>
-              </a:rPr>
-              <a:t> Provides consulting-grade suggestions detailing weekly cost savings.</a:t>
-            </a:r>
-          </a:p>
-          <a:p>
-            <a:pPr>
-              <a:spcAft>
-                <a:spcPts val="1400"/>
-              </a:spcAft>
-            </a:pPr>
-            <a:r>
-              <a:rPr sz="1800" b="1">
-                <a:solidFill>
-                  <a:srgbClr val="FAFAFA"/>
-                </a:solidFill>
-                <a:latin typeface="Arial"/>
-              </a:rPr>
-              <a:t>Technical Fallback Rules:</a:t>
-            </a:r>
-            <a:r>
-              <a:rPr sz="1800">
-                <a:solidFill>
-                  <a:srgbClr val="A1A1AA"/>
-                </a:solidFill>
-                <a:latin typeface="Arial"/>
-              </a:rPr>
-              <a:t> Rule-based fallback executes on the database if the LLM API is offline.</a:t>
-            </a:r>
-          </a:p>
-        </p:txBody>
-      </p:sp>
+                <a:spcPts val="1000"/>
+              </a:spcAft>
+            </a:pPr>
+            <a:r>
+              <a:rPr sz="1300" b="1">
+                <a:solidFill>
+                  <a:srgbClr val="FAFAFA"/>
+                </a:solidFill>
+                <a:latin typeface="Arial"/>
+              </a:rPr>
+              <a:t>Conversational Interface (casestudy.png):</a:t>
+            </a:r>
+            <a:r>
+              <a:rPr sz="1300">
+                <a:solidFill>
+                  <a:srgbClr val="A1A1AA"/>
+                </a:solidFill>
+                <a:latin typeface="Arial"/>
+              </a:rPr>
+              <a:t> Provides context-enriched advisory panels displaying strategic plans.</a:t>
+            </a:r>
+          </a:p>
+          <a:p>
+            <a:pPr>
+              <a:spcAft>
+                <a:spcPts val="1000"/>
+              </a:spcAft>
+            </a:pPr>
+            <a:r>
+              <a:rPr sz="1300" b="1">
+                <a:solidFill>
+                  <a:srgbClr val="FAFAFA"/>
+                </a:solidFill>
+                <a:latin typeface="Arial"/>
+              </a:rPr>
+              <a:t>Direct Answers:</a:t>
+            </a:r>
+            <a:r>
+              <a:rPr sz="1300">
+                <a:solidFill>
+                  <a:srgbClr val="A1A1AA"/>
+                </a:solidFill>
+                <a:latin typeface="Arial"/>
+              </a:rPr>
+              <a:t> Responds to inquiries like 'How can I reduce costs by 20%?' with detailed, multi-step actions.</a:t>
+            </a:r>
+          </a:p>
+          <a:p>
+            <a:pPr>
+              <a:spcAft>
+                <a:spcPts val="1000"/>
+              </a:spcAft>
+            </a:pPr>
+            <a:r>
+              <a:rPr sz="1300" b="1">
+                <a:solidFill>
+                  <a:srgbClr val="FAFAFA"/>
+                </a:solidFill>
+                <a:latin typeface="Arial"/>
+              </a:rPr>
+              <a:t>Fallback Rules:</a:t>
+            </a:r>
+            <a:r>
+              <a:rPr sz="1300">
+                <a:solidFill>
+                  <a:srgbClr val="A1A1AA"/>
+                </a:solidFill>
+                <a:latin typeface="Arial"/>
+              </a:rPr>
+              <a:t> Implements rule-based fallback logic to analyze local database statistics if the LLM API is offline.</a:t>
+            </a:r>
+          </a:p>
+          <a:p>
+            <a:pPr>
+              <a:spcAft>
+                <a:spcPts val="1000"/>
+              </a:spcAft>
+            </a:pPr>
+            <a:r>
+              <a:rPr sz="1300" b="1">
+                <a:solidFill>
+                  <a:srgbClr val="FAFAFA"/>
+                </a:solidFill>
+                <a:latin typeface="Arial"/>
+              </a:rPr>
+              <a:t>Action Chips:</a:t>
+            </a:r>
+            <a:r>
+              <a:rPr sz="1300">
+                <a:solidFill>
+                  <a:srgbClr val="A1A1AA"/>
+                </a:solidFill>
+                <a:latin typeface="Arial"/>
+              </a:rPr>
+              <a:t> Interactive cards allowing users to click common queries instantly.</a:t>
+            </a:r>
+          </a:p>
+        </p:txBody>
+      </p:sp>
+      <p:pic>
+        <p:nvPicPr>
+          <p:cNvPr id="4" name="Picture 3" descr="casestudy.png"/>
+          <p:cNvPicPr>
+            <a:picLocks noChangeAspect="1"/>
+          </p:cNvPicPr>
+          <p:nvPr/>
+        </p:nvPicPr>
+        <p:blipFill>
+          <a:blip r:embed="rId2"/>
+          <a:stretch>
+            <a:fillRect/>
+          </a:stretch>
+        </p:blipFill>
+        <p:spPr>
+          <a:xfrm>
+            <a:off x="4754880" y="1280160"/>
+            <a:ext cx="3931920" cy="2232184"/>
+          </a:xfrm>
+          <a:prstGeom prst="rect">
+            <a:avLst/>
+          </a:prstGeom>
+        </p:spPr>
+      </p:pic>
     </p:spTree>
   </p:cSld>
   <p:clrMapOvr>
@@ -5322,8 +5418,8 @@
         </p:nvSpPr>
         <p:spPr>
           <a:xfrm>
-            <a:off x="457200" y="1371600"/>
-            <a:ext cx="8229600" cy="4572000"/>
+            <a:off x="457200" y="1280160"/>
+            <a:ext cx="4114800" cy="3474720"/>
           </a:xfrm>
           <a:prstGeom prst="rect">
             <a:avLst/>
@@ -5338,11 +5434,36 @@
           <a:p>
             <a:pPr>
               <a:spcAft>
-                <a:spcPts val="1400"/>
-              </a:spcAft>
-            </a:pPr>
-            <a:r>
-              <a:rPr sz="1800" b="1">
+                <a:spcPts val="1000"/>
+              </a:spcAft>
+            </a:pPr>
+            <a:r>
+              <a:rPr sz="1300" b="1">
+                <a:solidFill>
+                  <a:srgbClr val="FAFAFA"/>
+                </a:solidFill>
+                <a:latin typeface="Arial"/>
+              </a:rPr>
+              <a:t>Audit Log Viewer (admin_logs.png):</a:t>
+            </a:r>
+            <a:r>
+              <a:rPr sz="1300">
+                <a:solidFill>
+                  <a:srgbClr val="A1A1AA"/>
+                </a:solidFill>
+                <a:latin typeface="Arial"/>
+              </a:rPr>
+              <a:t> Renders secure table logging details of all system modifications.</a:t>
+            </a:r>
+          </a:p>
+          <a:p>
+            <a:pPr>
+              <a:spcAft>
+                <a:spcPts val="1000"/>
+              </a:spcAft>
+            </a:pPr>
+            <a:r>
+              <a:rPr sz="1300" b="1">
                 <a:solidFill>
                   <a:srgbClr val="FAFAFA"/>
                 </a:solidFill>
@@ -5351,7 +5472,7 @@
               <a:t>Access Protection:</a:t>
             </a:r>
             <a:r>
-              <a:rPr sz="1800">
+              <a:rPr sz="1300">
                 <a:solidFill>
                   <a:srgbClr val="A1A1AA"/>
                 </a:solidFill>
@@ -5363,11 +5484,11 @@
           <a:p>
             <a:pPr>
               <a:spcAft>
-                <a:spcPts val="1400"/>
-              </a:spcAft>
-            </a:pPr>
-            <a:r>
-              <a:rPr sz="1800" b="1">
+                <a:spcPts val="1000"/>
+              </a:spcAft>
+            </a:pPr>
+            <a:r>
+              <a:rPr sz="1300" b="1">
                 <a:solidFill>
                   <a:srgbClr val="FAFAFA"/>
                 </a:solidFill>
@@ -5376,7 +5497,7 @@
               <a:t>Type Safety Validation:</a:t>
             </a:r>
             <a:r>
-              <a:rPr sz="1800">
+              <a:rPr sz="1300">
                 <a:solidFill>
                   <a:srgbClr val="A1A1AA"/>
                 </a:solidFill>
@@ -5388,11 +5509,11 @@
           <a:p>
             <a:pPr>
               <a:spcAft>
-                <a:spcPts val="1400"/>
-              </a:spcAft>
-            </a:pPr>
-            <a:r>
-              <a:rPr sz="1800" b="1">
+                <a:spcPts val="1000"/>
+              </a:spcAft>
+            </a:pPr>
+            <a:r>
+              <a:rPr sz="1300" b="1">
                 <a:solidFill>
                   <a:srgbClr val="FAFAFA"/>
                 </a:solidFill>
@@ -5401,7 +5522,7 @@
               <a:t>SQL Injection Prevention:</a:t>
             </a:r>
             <a:r>
-              <a:rPr sz="1800">
+              <a:rPr sz="1300">
                 <a:solidFill>
                   <a:srgbClr val="A1A1AA"/>
                 </a:solidFill>
@@ -5410,33 +5531,32 @@
               <a:t> Parameterized queries in SQLAlchemy ORM eliminate injection vectors.</a:t>
             </a:r>
           </a:p>
-          <a:p>
-            <a:pPr>
-              <a:spcAft>
-                <a:spcPts val="1400"/>
-              </a:spcAft>
-            </a:pPr>
-            <a:r>
-              <a:rPr sz="1800" b="1">
-                <a:solidFill>
-                  <a:srgbClr val="FAFAFA"/>
-                </a:solidFill>
-                <a:latin typeface="Arial"/>
-              </a:rPr>
-              <a:t>CORS Access Controls:</a:t>
-            </a:r>
-            <a:r>
-              <a:rPr sz="1800">
-                <a:solidFill>
-                  <a:srgbClr val="A1A1AA"/>
-                </a:solidFill>
-                <a:latin typeface="Arial"/>
-              </a:rPr>
-              <a:t> Restricted origins block unauthorized external domains from querying backend API endpoints.</a:t>
-            </a:r>
-          </a:p>
-        </p:txBody>
-      </p:sp>
+        </p:txBody>
+      </p:sp>
+      <p:pic>
+        <p:nvPicPr>
+          <p:cNvPr id="4" name="Picture 3" descr="admin_logs.png"/>
+          <p:cNvPicPr>
+            <a:picLocks noChangeAspect="1"/>
+          </p:cNvPicPr>
+          <p:nvPr/>
+        </p:nvPicPr>
+        <p:blipFill>
+          <a:blip r:embed="rId2"/>
+          <a:stretch>
+            <a:fillRect/>
+          </a:stretch>
+        </p:blipFill>
+        <p:spPr>
+          <a:xfrm>
+            <a:off x="4754880" y="1280160"/>
+            <a:ext cx="3931920" cy="2232184"/>
+          </a:xfrm>
+          <a:prstGeom prst="rect">
+            <a:avLst/>
+          </a:prstGeom>
+        </p:spPr>
+      </p:pic>
     </p:spTree>
   </p:cSld>
   <p:clrMapOvr>
@@ -6247,8 +6367,8 @@
         </p:nvSpPr>
         <p:spPr>
           <a:xfrm>
-            <a:off x="457200" y="1371600"/>
-            <a:ext cx="8229600" cy="4572000"/>
+            <a:off x="457200" y="1280160"/>
+            <a:ext cx="4114800" cy="3474720"/>
           </a:xfrm>
           <a:prstGeom prst="rect">
             <a:avLst/>
@@ -6263,11 +6383,11 @@
           <a:p>
             <a:pPr>
               <a:spcAft>
-                <a:spcPts val="1400"/>
-              </a:spcAft>
-            </a:pPr>
-            <a:r>
-              <a:rPr sz="1800" b="1">
+                <a:spcPts val="1000"/>
+              </a:spcAft>
+            </a:pPr>
+            <a:r>
+              <a:rPr sz="1300" b="1">
                 <a:solidFill>
                   <a:srgbClr val="FAFAFA"/>
                 </a:solidFill>
@@ -6276,7 +6396,7 @@
               <a:t>Recruiter-Ready Platform:</a:t>
             </a:r>
             <a:r>
-              <a:rPr sz="1800">
+              <a:rPr sz="1300">
                 <a:solidFill>
                   <a:srgbClr val="A1A1AA"/>
                 </a:solidFill>
@@ -6288,36 +6408,36 @@
           <a:p>
             <a:pPr>
               <a:spcAft>
-                <a:spcPts val="1400"/>
-              </a:spcAft>
-            </a:pPr>
-            <a:r>
-              <a:rPr sz="1800" b="1">
-                <a:solidFill>
-                  <a:srgbClr val="FAFAFA"/>
-                </a:solidFill>
-                <a:latin typeface="Arial"/>
-              </a:rPr>
-              <a:t>Sophisticated Calculations:</a:t>
-            </a:r>
-            <a:r>
-              <a:rPr sz="1800">
-                <a:solidFill>
-                  <a:srgbClr val="A1A1AA"/>
-                </a:solidFill>
-                <a:latin typeface="Arial"/>
-              </a:rPr>
-              <a:t> Implements custom formulas (GICP, MCES, SLA-VEI, COROI) on local telemetry.</a:t>
-            </a:r>
-          </a:p>
-          <a:p>
-            <a:pPr>
-              <a:spcAft>
-                <a:spcPts val="1400"/>
-              </a:spcAft>
-            </a:pPr>
-            <a:r>
-              <a:rPr sz="1800" b="1">
+                <a:spcPts val="1000"/>
+              </a:spcAft>
+            </a:pPr>
+            <a:r>
+              <a:rPr sz="1300" b="1">
+                <a:solidFill>
+                  <a:srgbClr val="FAFAFA"/>
+                </a:solidFill>
+                <a:latin typeface="Arial"/>
+              </a:rPr>
+              <a:t>Designed UI (login.png):</a:t>
+            </a:r>
+            <a:r>
+              <a:rPr sz="1300">
+                <a:solidFill>
+                  <a:srgbClr val="A1A1AA"/>
+                </a:solidFill>
+                <a:latin typeface="Arial"/>
+              </a:rPr>
+              <a:t> Offers secure credentials authentication layout using Zinc dark themes.</a:t>
+            </a:r>
+          </a:p>
+          <a:p>
+            <a:pPr>
+              <a:spcAft>
+                <a:spcPts val="1000"/>
+              </a:spcAft>
+            </a:pPr>
+            <a:r>
+              <a:rPr sz="1300" b="1">
                 <a:solidFill>
                   <a:srgbClr val="FAFAFA"/>
                 </a:solidFill>
@@ -6326,7 +6446,7 @@
               <a:t>Production-Grade Performance:</a:t>
             </a:r>
             <a:r>
-              <a:rPr sz="1800">
+              <a:rPr sz="1300">
                 <a:solidFill>
                   <a:srgbClr val="A1A1AA"/>
                 </a:solidFill>
@@ -6338,11 +6458,11 @@
           <a:p>
             <a:pPr>
               <a:spcAft>
-                <a:spcPts val="1400"/>
-              </a:spcAft>
-            </a:pPr>
-            <a:r>
-              <a:rPr sz="1800" b="1">
+                <a:spcPts val="1000"/>
+              </a:spcAft>
+            </a:pPr>
+            <a:r>
+              <a:rPr sz="1300" b="1">
                 <a:solidFill>
                   <a:srgbClr val="FAFAFA"/>
                 </a:solidFill>
@@ -6351,7 +6471,7 @@
               <a:t>Advanced Competency:</a:t>
             </a:r>
             <a:r>
-              <a:rPr sz="1800">
+              <a:rPr sz="1300">
                 <a:solidFill>
                   <a:srgbClr val="A1A1AA"/>
                 </a:solidFill>
@@ -6362,6 +6482,30 @@
           </a:p>
         </p:txBody>
       </p:sp>
+      <p:pic>
+        <p:nvPicPr>
+          <p:cNvPr id="4" name="Picture 3" descr="login.png"/>
+          <p:cNvPicPr>
+            <a:picLocks noChangeAspect="1"/>
+          </p:cNvPicPr>
+          <p:nvPr/>
+        </p:nvPicPr>
+        <p:blipFill>
+          <a:blip r:embed="rId2"/>
+          <a:stretch>
+            <a:fillRect/>
+          </a:stretch>
+        </p:blipFill>
+        <p:spPr>
+          <a:xfrm>
+            <a:off x="4754880" y="1280160"/>
+            <a:ext cx="3931920" cy="2232184"/>
+          </a:xfrm>
+          <a:prstGeom prst="rect">
+            <a:avLst/>
+          </a:prstGeom>
+        </p:spPr>
+      </p:pic>
     </p:spTree>
   </p:cSld>
   <p:clrMapOvr>
@@ -6652,7 +6796,7 @@
                 </a:solidFill>
                 <a:latin typeface="Arial"/>
               </a:rPr>
-              <a:t> Up to 60% of GPU compute budgets are wasted on idle allocations.</a:t>
+              <a:t> Over 60% of GPU compute budgets are wasted on idle allocations.</a:t>
             </a:r>
           </a:p>
           <a:p>

</xml_diff>